<commit_message>
docs: finalize submission deck release assets
Replace v0.3-alpha label with v1.0-submission across deck slides 1+10, README badge, hackathon README, and submission-form. Refresh homepage screenshot showing the new For-judges guidance card and regenerate slide 6 caption to match. Rebuild PDF (677 KB) and PPTX (1.99 MB).

Co-authored-by: Copilot <223556219+Copilot@users.noreply.github.com>
</commit_message>
<xml_diff>
--- a/docs/hackathon/VentureOS-Submission-Deck.pptx
+++ b/docs/hackathon/VentureOS-Submission-Deck.pptx
@@ -2301,7 +2301,7 @@
                 <a:ea typeface="Calibri" pitchFamily="34" charset="-122"/>
                 <a:cs typeface="Calibri" pitchFamily="34" charset="-120"/>
               </a:rPr>
-              <a:t>Amit Pandey · Microsoft Build AI / HackerEarth · v0.3-alpha</a:t>
+              <a:t>Amit Pandey · Microsoft Build AI / HackerEarth · v1.0-submission</a:t>
             </a:r>
             <a:endParaRPr lang="en-US" sz="1100" dirty="0"/>
           </a:p>
@@ -2712,7 +2712,7 @@
                 <a:ea typeface="Consolas" pitchFamily="34" charset="-122"/>
                 <a:cs typeface="Consolas" pitchFamily="34" charset="-120"/>
               </a:rPr>
-              <a:t>Tagged release: v0.3-alpha</a:t>
+              <a:t>Tagged release: v1.0-submission</a:t>
             </a:r>
             <a:endParaRPr lang="en-US" sz="1100" dirty="0"/>
           </a:p>
@@ -7832,7 +7832,7 @@
                 <a:ea typeface="Calibri" pitchFamily="34" charset="-122"/>
                 <a:cs typeface="Calibri" pitchFamily="34" charset="-120"/>
               </a:rPr>
-              <a:t>Homepage · agent swarm hero + pipeline</a:t>
+              <a:t>Homepage · "For judges" guidance + agent swarm pipeline</a:t>
             </a:r>
             <a:endParaRPr lang="en-US" sz="1000" dirty="0"/>
           </a:p>

</xml_diff>

<commit_message>
docs: finalize submission deck release assets (#9)
Replace v0.3-alpha label with v1.0-submission across deck slides 1+10, README badge, hackathon README, and submission-form. Refresh homepage screenshot showing the new For-judges guidance card and regenerate slide 6 caption to match. Rebuild PDF (677 KB) and PPTX (1.99 MB).

Co-authored-by: Amit Pandey <pandeyamit@microsoft.com>
Co-authored-by: Copilot <223556219+Copilot@users.noreply.github.com>
</commit_message>
<xml_diff>
--- a/docs/hackathon/VentureOS-Submission-Deck.pptx
+++ b/docs/hackathon/VentureOS-Submission-Deck.pptx
@@ -2301,7 +2301,7 @@
                 <a:ea typeface="Calibri" pitchFamily="34" charset="-122"/>
                 <a:cs typeface="Calibri" pitchFamily="34" charset="-120"/>
               </a:rPr>
-              <a:t>Amit Pandey · Microsoft Build AI / HackerEarth · v0.3-alpha</a:t>
+              <a:t>Amit Pandey · Microsoft Build AI / HackerEarth · v1.0-submission</a:t>
             </a:r>
             <a:endParaRPr lang="en-US" sz="1100" dirty="0"/>
           </a:p>
@@ -2712,7 +2712,7 @@
                 <a:ea typeface="Consolas" pitchFamily="34" charset="-122"/>
                 <a:cs typeface="Consolas" pitchFamily="34" charset="-120"/>
               </a:rPr>
-              <a:t>Tagged release: v0.3-alpha</a:t>
+              <a:t>Tagged release: v1.0-submission</a:t>
             </a:r>
             <a:endParaRPr lang="en-US" sz="1100" dirty="0"/>
           </a:p>
@@ -7832,7 +7832,7 @@
                 <a:ea typeface="Calibri" pitchFamily="34" charset="-122"/>
                 <a:cs typeface="Calibri" pitchFamily="34" charset="-120"/>
               </a:rPr>
-              <a:t>Homepage · agent swarm hero + pipeline</a:t>
+              <a:t>Homepage · "For judges" guidance + agent swarm pipeline</a:t>
             </a:r>
             <a:endParaRPr lang="en-US" sz="1000" dirty="0"/>
           </a:p>

</xml_diff>